<commit_message>
Update merge quebrado, e revisão na parte textextual
</commit_message>
<xml_diff>
--- a/docs/poster_mostraTCC1_2026-2_agro.pptx
+++ b/docs/poster_mostraTCC1_2026-2_agro.pptx
@@ -1600,7 +1600,7 @@
                 </a:solidFill>
                 <a:latin typeface="Segoe UI Variable Display" pitchFamily="2" charset="0"/>
               </a:rPr>
-              <a:t>RESULTADOS PRÉVIOS / ESPERADOS</a:t>
+              <a:t>RESULTADOS</a:t>
             </a:r>
           </a:p>
         </p:txBody>
@@ -3345,7 +3345,7 @@
               <a:rPr lang="pt-BR" sz="2236" noProof="1" b="0">
                 <a:latin typeface="system-ui"/>
               </a:rPr>
-              <a:t>Avaliar VaR e ES e incorporar o benchmark MS-GARCH.</a:t>
+              <a:t>Avaliar VaR e ES frente ao benchmark MS-GARCH.</a:t>
             </a:r>
           </a:p>
         </p:txBody>
@@ -3434,7 +3434,7 @@
               <a:rPr lang="pt-BR" sz="2236" noProof="1" b="0">
                 <a:latin typeface="system-ui"/>
               </a:rPr>
-              <a:t>VaR e ES a 95% e 99% por erros de calibração e escala EWMA. MS-GARCH previsto como benchmark.</a:t>
+              <a:t>VaR e ES a 95% e 99% por FHS com escala EWMA. MS-GARCH Student-t ajustado em cada janela.</a:t>
             </a:r>
           </a:p>
         </p:txBody>
@@ -3478,7 +3478,7 @@
               <a:rPr lang="pt-BR" sz="2236" noProof="1" b="0">
                 <a:latin typeface="system-ui"/>
               </a:rPr>
-              <a:t>Rodada exploratória: 23 janelas e 2.717 previsões por modelo, de outubro de 2012 a março de 2024.</a:t>
+              <a:t>Rodada executada: 23 janelas e 2.717 previsões por modelo, de outubro de 2012 a março de 2024.</a:t>
             </a:r>
           </a:p>
           <a:p>
@@ -3493,7 +3493,7 @@
               <a:rPr lang="pt-BR" sz="2236" noProof="1" b="0">
                 <a:latin typeface="system-ui"/>
               </a:rPr>
-              <a:t>No VaR a 95%, as violações passam de cerca de 5% no total para 6,6% a 8,0% nos dias de estresse.</a:t>
+              <a:t>No estresse, o VaR a 95% tem 8,0% de violações na HMM-LSTM e 6,6% no MS-GARCH. Os escores favorecem o benchmark.</a:t>
             </a:r>
           </a:p>
         </p:txBody>
@@ -3613,7 +3613,7 @@
               <a:rPr lang="pt-BR" sz="2236" noProof="1" b="0">
                 <a:latin typeface="system-ui"/>
               </a:rPr>
-              <a:t>Modelos de regimes descrevem mudanças persistentes. Redes LSTM aprendem relações temporais. A combinação será avaliada sem presumir superioridade, distinguindo previsão do retorno e calibração do risco (Hamilton, 1989; Hochreiter; Schmidhuber, 1997).</a:t>
+              <a:t>Regimes descrevem mudanças persistentes; redes LSTM aprendem relações temporais (Hamilton, 1989; Hochreiter; Schmidhuber, 1997). Na calibração conjunta, as entradas de regime não melhoraram os escores totais frente à LSTM.</a:t>
             </a:r>
           </a:p>
         </p:txBody>
@@ -3653,7 +3653,7 @@
               <a:rPr lang="pt-BR" sz="1800" b="0" noProof="1">
                 <a:latin typeface="system-ui"/>
               </a:rPr>
-              <a:t>Figura 1 – Composição do índice proposto: sete componentes com peso de 1/7.</a:t>
+              <a:t>Figura 1 – Composição do índice: sete componentes com peso de 1/7.</a:t>
             </a:r>
           </a:p>
         </p:txBody>
@@ -4072,7 +4072,7 @@
               <a:rPr lang="pt-BR" sz="1800" b="0" noProof="1">
                 <a:latin typeface="system-ui"/>
               </a:rPr>
-              <a:t>Fonte: elaboração do autor (2026). Dados e rolagens em validação. MS-GARCH pendente.</a:t>
+              <a:t>Fonte: elaboração do autor (2026). Índice de preços; custos de rolagem não incluídos.</a:t>
             </a:r>
           </a:p>
         </p:txBody>

</xml_diff>